<commit_message>
Anexo del caso de estudio Huellitas y su conexion con el material
Co-Authored-By: Claude Opus 5 <noreply@anthropic.com>
</commit_message>
<xml_diff>
--- a/Bases de Datos II/Clases/Clase 1 - Revision BD I y arranque VetCare/Presentacion.pptx
+++ b/Bases de Datos II/Clases/Clase 1 - Revision BD I y arranque VetCare/Presentacion.pptx
@@ -9862,7 +9862,7 @@
               </a:spcAft>
             </a:pPr>
             <a:r>
-              <a:rPr sz="1500" b="0" i="0">
+              <a:rPr sz="1400" b="0" i="0">
                 <a:solidFill>
                   <a:srgbClr val="333333"/>
                 </a:solidFill>
@@ -9871,7 +9871,7 @@
               <a:t>–   </a:t>
             </a:r>
             <a:r>
-              <a:rPr sz="1500" b="1" i="0">
+              <a:rPr sz="1400" b="1" i="0">
                 <a:solidFill>
                   <a:srgbClr val="333333"/>
                 </a:solidFill>
@@ -9880,13 +9880,67 @@
               <a:t>Clínica Veterinaria «Huellitas»</a:t>
             </a:r>
             <a:r>
-              <a:rPr sz="1500" b="0" i="0">
+              <a:rPr sz="1400" b="0" i="0">
                 <a:solidFill>
                   <a:srgbClr val="333333"/>
                 </a:solidFill>
                 <a:latin typeface="Calibri"/>
               </a:rPr>
-              <a:t> lleva su gestión en papel y quiere un sistema. Tres personas lo van a usar:</a:t>
+              <a:t> (Cali): unas </a:t>
+            </a:r>
+            <a:r>
+              <a:rPr sz="1400" b="1" i="0">
+                <a:solidFill>
+                  <a:srgbClr val="333333"/>
+                </a:solidFill>
+                <a:latin typeface="Calibri"/>
+              </a:rPr>
+              <a:t>150 citas al día</a:t>
+            </a:r>
+            <a:r>
+              <a:rPr sz="1400" b="0" i="0">
+                <a:solidFill>
+                  <a:srgbClr val="333333"/>
+                </a:solidFill>
+                <a:latin typeface="Calibri"/>
+              </a:rPr>
+              <a:t>, </a:t>
+            </a:r>
+            <a:r>
+              <a:rPr sz="1400" b="1" i="0">
+                <a:solidFill>
+                  <a:srgbClr val="333333"/>
+                </a:solidFill>
+                <a:latin typeface="Calibri"/>
+              </a:rPr>
+              <a:t>16 veterinarios</a:t>
+            </a:r>
+            <a:r>
+              <a:rPr sz="1400" b="0" i="0">
+                <a:solidFill>
+                  <a:srgbClr val="333333"/>
+                </a:solidFill>
+                <a:latin typeface="Calibri"/>
+              </a:rPr>
+              <a:t>, ~5.000 mascotas de ~2.000 dueños — y todo en </a:t>
+            </a:r>
+            <a:r>
+              <a:rPr sz="1400" b="1" i="0">
+                <a:solidFill>
+                  <a:srgbClr val="333333"/>
+                </a:solidFill>
+                <a:latin typeface="Calibri"/>
+              </a:rPr>
+              <a:t>carpetas de papel</a:t>
+            </a:r>
+            <a:r>
+              <a:rPr sz="1400" b="0" i="0">
+                <a:solidFill>
+                  <a:srgbClr val="333333"/>
+                </a:solidFill>
+                <a:latin typeface="Calibri"/>
+              </a:rPr>
+              <a:t>.</a:t>
             </a:r>
           </a:p>
           <a:p>
@@ -9896,31 +9950,13 @@
               </a:spcAft>
             </a:pPr>
             <a:r>
-              <a:rPr sz="1500" b="0" i="0">
+              <a:rPr sz="1400" b="0" i="0">
                 <a:solidFill>
                   <a:srgbClr val="333333"/>
                 </a:solidFill>
                 <a:latin typeface="Calibri"/>
               </a:rPr>
-              <a:t>–   </a:t>
-            </a:r>
-            <a:r>
-              <a:rPr sz="1500" b="1" i="0">
-                <a:solidFill>
-                  <a:srgbClr val="333333"/>
-                </a:solidFill>
-                <a:latin typeface="Calibri"/>
-              </a:rPr>
-              <a:t>Dueño de la clínica:</a:t>
-            </a:r>
-            <a:r>
-              <a:rPr sz="1500" b="0" i="0">
-                <a:solidFill>
-                  <a:srgbClr val="333333"/>
-                </a:solidFill>
-                <a:latin typeface="Calibri"/>
-              </a:rPr>
-              <a:t> quiere métricas del negocio.</a:t>
+              <a:t>–   Duele en tres puntos: se extravían fichas, buscar un historial genera filas en la sala de espera, y no hay métricas.</a:t>
             </a:r>
           </a:p>
           <a:p>
@@ -9930,31 +9966,67 @@
               </a:spcAft>
             </a:pPr>
             <a:r>
-              <a:rPr sz="1500" b="0" i="0">
+              <a:rPr sz="1400" b="0" i="0">
                 <a:solidFill>
                   <a:srgbClr val="333333"/>
                 </a:solidFill>
                 <a:latin typeface="Calibri"/>
               </a:rPr>
-              <a:t>–   </a:t>
-            </a:r>
-            <a:r>
-              <a:rPr sz="1500" b="1" i="0">
+              <a:t>–   Tres personas van a usar el sistema, y esperan cosas distintas: </a:t>
+            </a:r>
+            <a:r>
+              <a:rPr sz="1400" b="1" i="0">
                 <a:solidFill>
                   <a:srgbClr val="333333"/>
                 </a:solidFill>
                 <a:latin typeface="Calibri"/>
               </a:rPr>
-              <a:t>Recepcionista:</a:t>
-            </a:r>
-            <a:r>
-              <a:rPr sz="1500" b="0" i="0">
+              <a:t>el dueño</a:t>
+            </a:r>
+            <a:r>
+              <a:rPr sz="1400" b="0" i="0">
                 <a:solidFill>
                   <a:srgbClr val="333333"/>
                 </a:solidFill>
                 <a:latin typeface="Calibri"/>
               </a:rPr>
-              <a:t> quiere agendar rápido y con pocos clics.</a:t>
+              <a:t> métricas, </a:t>
+            </a:r>
+            <a:r>
+              <a:rPr sz="1400" b="1" i="0">
+                <a:solidFill>
+                  <a:srgbClr val="333333"/>
+                </a:solidFill>
+                <a:latin typeface="Calibri"/>
+              </a:rPr>
+              <a:t>la recepcionista</a:t>
+            </a:r>
+            <a:r>
+              <a:rPr sz="1400" b="0" i="0">
+                <a:solidFill>
+                  <a:srgbClr val="333333"/>
+                </a:solidFill>
+                <a:latin typeface="Calibri"/>
+              </a:rPr>
+              <a:t> agendar rápido, </a:t>
+            </a:r>
+            <a:r>
+              <a:rPr sz="1400" b="1" i="0">
+                <a:solidFill>
+                  <a:srgbClr val="333333"/>
+                </a:solidFill>
+                <a:latin typeface="Calibri"/>
+              </a:rPr>
+              <a:t>el veterinario</a:t>
+            </a:r>
+            <a:r>
+              <a:rPr sz="1400" b="0" i="0">
+                <a:solidFill>
+                  <a:srgbClr val="333333"/>
+                </a:solidFill>
+                <a:latin typeface="Calibri"/>
+              </a:rPr>
+              <a:t> el historial a la mano.</a:t>
             </a:r>
           </a:p>
           <a:p>
@@ -9964,31 +10036,31 @@
               </a:spcAft>
             </a:pPr>
             <a:r>
-              <a:rPr sz="1500" b="0" i="0">
+              <a:rPr sz="1400" b="0" i="0">
                 <a:solidFill>
                   <a:srgbClr val="333333"/>
                 </a:solidFill>
                 <a:latin typeface="Calibri"/>
               </a:rPr>
-              <a:t>–   </a:t>
-            </a:r>
-            <a:r>
-              <a:rPr sz="1500" b="1" i="0">
+              <a:t>–   Sus intereses </a:t>
+            </a:r>
+            <a:r>
+              <a:rPr sz="1400" b="1" i="0">
                 <a:solidFill>
                   <a:srgbClr val="333333"/>
                 </a:solidFill>
                 <a:latin typeface="Calibri"/>
               </a:rPr>
-              <a:t>Veterinario:</a:t>
-            </a:r>
-            <a:r>
-              <a:rPr sz="1500" b="0" i="0">
+              <a:t>entran en conflicto</a:t>
+            </a:r>
+            <a:r>
+              <a:rPr sz="1400" b="0" i="0">
                 <a:solidFill>
                   <a:srgbClr val="333333"/>
                 </a:solidFill>
                 <a:latin typeface="Calibri"/>
               </a:rPr>
-              <a:t> quiere el historial del paciente a la mano durante la consulta.</a:t>
+              <a:t>: más datos dan mejores métricas, pero hacen más lento el agendamiento. Ahí están las decisiones de diseño del semestre.</a:t>
             </a:r>
           </a:p>
           <a:p>
@@ -9998,31 +10070,31 @@
               </a:spcAft>
             </a:pPr>
             <a:r>
-              <a:rPr sz="1500" b="0" i="0">
+              <a:rPr sz="1400" b="0" i="0">
                 <a:solidFill>
                   <a:srgbClr val="333333"/>
                 </a:solidFill>
                 <a:latin typeface="Calibri"/>
               </a:rPr>
-              <a:t>–   Sus intereses </a:t>
-            </a:r>
-            <a:r>
-              <a:rPr sz="1500" b="1" i="0">
+              <a:t>–   </a:t>
+            </a:r>
+            <a:r>
+              <a:rPr sz="1400" b="1" i="0">
                 <a:solidFill>
                   <a:srgbClr val="333333"/>
                 </a:solidFill>
                 <a:latin typeface="Calibri"/>
               </a:rPr>
-              <a:t>entran en conflicto</a:t>
-            </a:r>
-            <a:r>
-              <a:rPr sz="1500" b="0" i="0">
+              <a:t>Caso completo:</a:t>
+            </a:r>
+            <a:r>
+              <a:rPr sz="1400" b="0" i="0">
                 <a:solidFill>
                   <a:srgbClr val="333333"/>
                 </a:solidFill>
                 <a:latin typeface="Calibri"/>
               </a:rPr>
-              <a:t>: más datos dan mejores métricas, pero hacen más lento el agendamiento. Ahí están las decisiones de diseño del semestre.</a:t>
+              <a:t> anexo «Caso de estudio Clínica Huellitas» en Clases/Proyecto Integrador — 8 entidades, 3 reglas y el elenco de nombres.</a:t>
             </a:r>
           </a:p>
         </p:txBody>

</xml_diff>